<commit_message>
Use HTTPS custom-domain demo URL in docs and deck
Co-Authored-By: Claude Opus 5.5 <noreply@anthropic.com>
</commit_message>
<xml_diff>
--- a/submission/Penumbra_DataNova2026.pptx
+++ b/submission/Penumbra_DataNova2026.pptx
@@ -118,46 +118,46 @@
   <p:extLst>
     <p:ext uri="{521415D9-36F7-43E2-AB2F-B90AF26B5E84}">
       <p14:sectionLst xmlns:p14="http://schemas.microsoft.com/office/powerpoint/2010/main">
-        <p14:section name="Intro" id="{3874d0d2-b5f9-28b9-a90d-461939f37a83}">
+        <p14:section name="Intro" id="{0eac2a7e-76c6-6e63-a5f3-70acceb0b6fa}">
           <p14:sldIdLst>
             <p14:sldId id="256"/>
           </p14:sldIdLst>
         </p14:section>
-        <p14:section name="Problem" id="{c5acb0b3-7c05-f9fe-a3d4-9dbc422dcbda}">
+        <p14:section name="Problem" id="{9578002f-a2f7-e348-85f7-21ddb96996e6}">
           <p14:sldIdLst>
             <p14:sldId id="257"/>
           </p14:sldIdLst>
         </p14:section>
-        <p14:section name="Solution" id="{0033cffb-244e-f734-e29b-e558ab12e475}">
+        <p14:section name="Solution" id="{0edd3e59-55ee-85ef-3104-47c5061401b0}">
           <p14:sldIdLst>
             <p14:sldId id="258"/>
           </p14:sldIdLst>
         </p14:section>
-        <p14:section name="Data &amp; method" id="{a77cf778-1ee1-5895-cba5-d6ed17d6970e}">
+        <p14:section name="Data &amp; method" id="{eb757f6d-a007-04d4-0bbd-c391d78e21e4}">
           <p14:sldIdLst>
             <p14:sldId id="259"/>
             <p14:sldId id="260"/>
           </p14:sldIdLst>
         </p14:section>
-        <p14:section name="Results" id="{e1d06c9e-163f-fd84-d403-c80eb37aa2ec}">
+        <p14:section name="Results" id="{5ebb4526-1bd9-6253-39e7-3eac7f387d36}">
           <p14:sldIdLst>
             <p14:sldId id="261"/>
             <p14:sldId id="262"/>
             <p14:sldId id="263"/>
           </p14:sldIdLst>
         </p14:section>
-        <p14:section name="Impact" id="{dde85618-f1cb-a726-c5ec-e1ba46b52a82}">
+        <p14:section name="Impact" id="{440db8e3-acc0-5fa4-1c8a-59e32afb2fc0}">
           <p14:sldIdLst>
             <p14:sldId id="264"/>
             <p14:sldId id="265"/>
           </p14:sldIdLst>
         </p14:section>
-        <p14:section name="Demo" id="{30fc7bc8-6e53-60ed-bf82-c9b51078e394}">
+        <p14:section name="Demo" id="{5cc853cb-ab01-2ce8-55da-16e6727397c7}">
           <p14:sldIdLst>
             <p14:sldId id="266"/>
           </p14:sldIdLst>
         </p14:section>
-        <p14:section name="Close" id="{f0bd1a18-a675-4cc1-8511-90359835ead1}">
+        <p14:section name="Close" id="{51d08898-88d3-75e4-0c21-f55d0098b922}">
           <p14:sldIdLst>
             <p14:sldId id="267"/>
           </p14:sldIdLst>
@@ -5388,7 +5388,7 @@
                   </a:extLst>
                 </a:hlinkClick>
               </a:rPr>
-              <a:t>https://s-kkipie.github.io/penumbra-solar-forecast/</a:t>
+              <a:t>https://skkippie.me/penumbra-solar-forecast/</a:t>
             </a:r>
             <a:endParaRPr lang="en-US" sz="1400" dirty="0"/>
           </a:p>
@@ -6123,7 +6123,7 @@
                   </a:extLst>
                 </a:hlinkClick>
               </a:rPr>
-              <a:t>https://s-kkipie.github.io/penumbra-solar-forecast/</a:t>
+              <a:t>https://skkippie.me/penumbra-solar-forecast/</a:t>
             </a:r>
             <a:endParaRPr lang="en-US" sz="1100" dirty="0"/>
           </a:p>

</xml_diff>